<commit_message>
Add baseline v1 findings slide with EPE sweep chart to update deck
</commit_message>
<xml_diff>
--- a/docs/NeuFlow_v3_update.pptx
+++ b/docs/NeuFlow_v3_update.pptx
@@ -9,6 +9,7 @@
     <p:sldId id="257" r:id="rId4"/>
     <p:sldId id="258" r:id="rId5"/>
     <p:sldId id="259" r:id="rId6"/>
+    <p:sldId id="263" r:id="rId11"/>
     <p:sldId id="260" r:id="rId7"/>
     <p:sldId id="261" r:id="rId8"/>
     <p:sldId id="262" r:id="rId9"/>
@@ -8525,6 +8526,453 @@
       <p:transition spd="slow"/>
     </mc:Fallback>
   </mc:AlternateContent>
+</p:sld>
+</file>
+
+<file path=ppt/slides/slide8.xml><?xml version="1.0" encoding="utf-8"?>
+<p:sld xmlns:a="http://schemas.openxmlformats.org/drawingml/2006/main" xmlns:p="http://schemas.openxmlformats.org/presentationml/2006/main" xmlns:r="http://schemas.openxmlformats.org/officeDocument/2006/relationships">
+  <p:cSld>
+    <p:spTree>
+      <p:nvGrpSpPr>
+        <p:cNvPr id="1" name=""/>
+        <p:cNvGrpSpPr/>
+        <p:nvPr/>
+      </p:nvGrpSpPr>
+      <p:grpSpPr/>
+      <p:sp>
+        <p:nvSpPr>
+          <p:cNvPr id="2" name="TextBox 1"/>
+          <p:cNvSpPr txBox="1"/>
+          <p:nvPr/>
+        </p:nvSpPr>
+        <p:spPr>
+          <a:xfrm>
+            <a:off x="685800" y="384048"/>
+            <a:ext cx="10058400" cy="274320"/>
+          </a:xfrm>
+          <a:prstGeom prst="rect">
+            <a:avLst/>
+          </a:prstGeom>
+          <a:noFill/>
+        </p:spPr>
+        <p:txBody>
+          <a:bodyPr wrap="square">
+            <a:spAutoFit/>
+          </a:bodyPr>
+          <a:lstStyle/>
+          <a:p>
+            <a:r>
+              <a:rPr sz="1050" b="1">
+                <a:solidFill>
+                  <a:srgbClr val="1F4E79"/>
+                </a:solidFill>
+                <a:latin typeface="Calibri"/>
+              </a:rPr>
+              <a:t>UPDATE  ·  BASELINE V1 (V1-DEV BRANCH)</a:t>
+            </a:r>
+          </a:p>
+        </p:txBody>
+      </p:sp>
+      <p:sp>
+        <p:nvSpPr>
+          <p:cNvPr id="3" name="TextBox 2"/>
+          <p:cNvSpPr txBox="1"/>
+          <p:nvPr/>
+        </p:nvSpPr>
+        <p:spPr>
+          <a:xfrm>
+            <a:off x="667512" y="658368"/>
+            <a:ext cx="10789920" cy="731520"/>
+          </a:xfrm>
+          <a:prstGeom prst="rect">
+            <a:avLst/>
+          </a:prstGeom>
+          <a:noFill/>
+        </p:spPr>
+        <p:txBody>
+          <a:bodyPr wrap="square">
+            <a:spAutoFit/>
+          </a:bodyPr>
+          <a:lstStyle/>
+          <a:p>
+            <a:r>
+              <a:rPr sz="2400" b="1">
+                <a:solidFill>
+                  <a:srgbClr val="20242B"/>
+                </a:solidFill>
+                <a:latin typeface="Calibri"/>
+              </a:rPr>
+              <a:t>Corrected evaluation and a controlled baseline</a:t>
+            </a:r>
+          </a:p>
+        </p:txBody>
+      </p:sp>
+      <p:sp>
+        <p:nvSpPr>
+          <p:cNvPr id="4" name="TextBox 3"/>
+          <p:cNvSpPr txBox="1"/>
+          <p:nvPr/>
+        </p:nvSpPr>
+        <p:spPr>
+          <a:xfrm>
+            <a:off x="685800" y="1417320"/>
+            <a:ext cx="5120640" cy="292608"/>
+          </a:xfrm>
+          <a:prstGeom prst="rect">
+            <a:avLst/>
+          </a:prstGeom>
+          <a:noFill/>
+        </p:spPr>
+        <p:txBody>
+          <a:bodyPr wrap="square">
+            <a:spAutoFit/>
+          </a:bodyPr>
+          <a:lstStyle/>
+          <a:p>
+            <a:r>
+              <a:rPr sz="1100" b="1">
+                <a:solidFill>
+                  <a:srgbClr val="1F4E79"/>
+                </a:solidFill>
+                <a:latin typeface="Calibri"/>
+              </a:rPr>
+              <a:t>What changed</a:t>
+            </a:r>
+          </a:p>
+        </p:txBody>
+      </p:sp>
+      <p:sp>
+        <p:nvSpPr>
+          <p:cNvPr id="5" name="TextBox 4"/>
+          <p:cNvSpPr txBox="1"/>
+          <p:nvPr/>
+        </p:nvSpPr>
+        <p:spPr>
+          <a:xfrm>
+            <a:off x="685800" y="1737360"/>
+            <a:ext cx="5120640" cy="2743200"/>
+          </a:xfrm>
+          <a:prstGeom prst="rect">
+            <a:avLst/>
+          </a:prstGeom>
+          <a:noFill/>
+        </p:spPr>
+        <p:txBody>
+          <a:bodyPr wrap="square">
+            <a:spAutoFit/>
+          </a:bodyPr>
+          <a:lstStyle/>
+          <a:p>
+            <a:r>
+              <a:rPr sz="1150" b="0">
+                <a:solidFill>
+                  <a:srgbClr val="20242B"/>
+                </a:solidFill>
+                <a:latin typeface="Calibri"/>
+              </a:rPr>
+              <a:t>Per-pixel metrics (old numbers were per-frame statistics)</a:t>
+            </a:r>
+          </a:p>
+          <a:p>
+            <a:r>
+              <a:rPr sz="1150" b="0">
+                <a:solidFill>
+                  <a:srgbClr val="20242B"/>
+                </a:solidFill>
+                <a:latin typeface="Calibri"/>
+              </a:rPr>
+              <a:t>Train/eval refinement iterations matched (1+8, was 4+7 vs 1+8)</a:t>
+            </a:r>
+          </a:p>
+          <a:p>
+            <a:r>
+              <a:rPr sz="1150" b="0">
+                <a:solidFill>
+                  <a:srgbClr val="20242B"/>
+                </a:solidFill>
+                <a:latin typeface="Calibri"/>
+              </a:rPr>
+              <a:t>RAFT loss weighting (gamma 0.8) and OneCycle LR schedule</a:t>
+            </a:r>
+          </a:p>
+          <a:p>
+            <a:r>
+              <a:rPr sz="1150" b="0">
+                <a:solidFill>
+                  <a:srgbClr val="20242B"/>
+                </a:solidFill>
+                <a:latin typeface="Calibri"/>
+              </a:rPr>
+              <a:t>GT sampled at exact pixels (no interpolation blur at boundaries)</a:t>
+            </a:r>
+          </a:p>
+        </p:txBody>
+      </p:sp>
+      <p:sp>
+        <p:nvSpPr>
+          <p:cNvPr id="6" name="TextBox 5"/>
+          <p:cNvSpPr txBox="1"/>
+          <p:nvPr/>
+        </p:nvSpPr>
+        <p:spPr>
+          <a:xfrm>
+            <a:off x="685800" y="3337560"/>
+            <a:ext cx="5120640" cy="292608"/>
+          </a:xfrm>
+          <a:prstGeom prst="rect">
+            <a:avLst/>
+          </a:prstGeom>
+          <a:noFill/>
+        </p:spPr>
+        <p:txBody>
+          <a:bodyPr wrap="square">
+            <a:spAutoFit/>
+          </a:bodyPr>
+          <a:lstStyle/>
+          <a:p>
+            <a:r>
+              <a:rPr sz="1100" b="1">
+                <a:solidFill>
+                  <a:srgbClr val="1F4E79"/>
+                </a:solidFill>
+                <a:latin typeface="Calibri"/>
+              </a:rPr>
+              <a:t>Corrected reference points (per-pixel, 460M px)</a:t>
+            </a:r>
+          </a:p>
+        </p:txBody>
+      </p:sp>
+      <p:sp>
+        <p:nvSpPr>
+          <p:cNvPr id="7" name="TextBox 6"/>
+          <p:cNvSpPr txBox="1"/>
+          <p:nvPr/>
+        </p:nvSpPr>
+        <p:spPr>
+          <a:xfrm>
+            <a:off x="685800" y="3657600"/>
+            <a:ext cx="5120640" cy="2011680"/>
+          </a:xfrm>
+          <a:prstGeom prst="rect">
+            <a:avLst/>
+          </a:prstGeom>
+          <a:noFill/>
+        </p:spPr>
+        <p:txBody>
+          <a:bodyPr wrap="square">
+            <a:spAutoFit/>
+          </a:bodyPr>
+          <a:lstStyle/>
+          <a:p>
+            <a:r>
+              <a:rPr sz="1150" b="0">
+                <a:solidFill>
+                  <a:srgbClr val="20242B"/>
+                </a:solidFill>
+                <a:latin typeface="Calibri"/>
+              </a:rPr>
+              <a:t>NeuFlow v2:  2.32 px EPE  ·  77.6% 1px  ·  89.8% 3px</a:t>
+            </a:r>
+          </a:p>
+          <a:p>
+            <a:r>
+              <a:rPr sz="1150" b="0">
+                <a:solidFill>
+                  <a:srgbClr val="20242B"/>
+                </a:solidFill>
+                <a:latin typeface="Calibri"/>
+              </a:rPr>
+              <a:t>v3 untrained decoder (bilinear):  2.48 px  ·  74.7%  ·  88.2%</a:t>
+            </a:r>
+          </a:p>
+          <a:p>
+            <a:r>
+              <a:rPr sz="1150" b="0">
+                <a:solidFill>
+                  <a:srgbClr val="20242B"/>
+                </a:solidFill>
+                <a:latin typeface="Calibri"/>
+              </a:rPr>
+              <a:t>v3 best trained:  2.77 px @ 4K steps</a:t>
+            </a:r>
+          </a:p>
+          <a:p>
+            <a:r>
+              <a:rPr sz="1150" b="0">
+                <a:solidFill>
+                  <a:srgbClr val="20242B"/>
+                </a:solidFill>
+                <a:latin typeface="Calibri"/>
+              </a:rPr>
+              <a:t/>
+            </a:r>
+          </a:p>
+          <a:p>
+            <a:r>
+              <a:rPr sz="1150" b="0">
+                <a:solidFill>
+                  <a:srgbClr val="20242B"/>
+                </a:solidFill>
+                <a:latin typeface="Calibri"/>
+              </a:rPr>
+              <a:t>Finding: no trained checkpoint beats the untrained decoder.</a:t>
+            </a:r>
+          </a:p>
+          <a:p>
+            <a:r>
+              <a:rPr sz="1150" b="0">
+                <a:solidFill>
+                  <a:srgbClr val="20242B"/>
+                </a:solidFill>
+                <a:latin typeface="Calibri"/>
+              </a:rPr>
+              <a:t>Direct delta regression (x1248 amplification) adds noise faster</a:t>
+            </a:r>
+          </a:p>
+          <a:p>
+            <a:r>
+              <a:rPr sz="1150" b="0">
+                <a:solidFill>
+                  <a:srgbClr val="20242B"/>
+                </a:solidFill>
+                <a:latin typeface="Calibri"/>
+              </a:rPr>
+              <a:t>than signal; small dataset overfits late checkpoints.</a:t>
+            </a:r>
+          </a:p>
+        </p:txBody>
+      </p:sp>
+      <p:pic>
+        <p:nvPicPr>
+          <p:cNvPr id="8" name="Picture 7" descr="baseline_v1_sweep.png"/>
+          <p:cNvPicPr>
+            <a:picLocks noChangeAspect="1"/>
+          </p:cNvPicPr>
+          <p:nvPr/>
+        </p:nvPicPr>
+        <p:blipFill>
+          <a:blip r:embed="rId2"/>
+          <a:stretch>
+            <a:fillRect/>
+          </a:stretch>
+        </p:blipFill>
+        <p:spPr>
+          <a:xfrm>
+            <a:off x="6080760" y="1554480"/>
+            <a:ext cx="5577840" cy="2818706"/>
+          </a:xfrm>
+          <a:prstGeom prst="rect">
+            <a:avLst/>
+          </a:prstGeom>
+        </p:spPr>
+      </p:pic>
+      <p:sp>
+        <p:nvSpPr>
+          <p:cNvPr id="9" name="TextBox 8"/>
+          <p:cNvSpPr txBox="1"/>
+          <p:nvPr/>
+        </p:nvSpPr>
+        <p:spPr>
+          <a:xfrm>
+            <a:off x="960120" y="5806440"/>
+            <a:ext cx="10332720" cy="548640"/>
+          </a:xfrm>
+          <a:prstGeom prst="rect">
+            <a:avLst/>
+          </a:prstGeom>
+          <a:noFill/>
+        </p:spPr>
+        <p:txBody>
+          <a:bodyPr wrap="square">
+            <a:spAutoFit/>
+          </a:bodyPr>
+          <a:lstStyle/>
+          <a:p>
+            <a:r>
+              <a:rPr sz="1150" b="1">
+                <a:solidFill>
+                  <a:srgbClr val="1F4E79"/>
+                </a:solidFill>
+                <a:latin typeface="Calibri"/>
+              </a:rPr>
+              <a:t>Takeaway   Queryable flow already costs only +0.16 px over v2 with zero decoder training. Next: bounded convex-weight head (AnyFlow-style) + 6x training data from same-trajectory VKITTI2 variants (v2-dev).</a:t>
+            </a:r>
+          </a:p>
+        </p:txBody>
+      </p:sp>
+      <p:sp>
+        <p:nvSpPr>
+          <p:cNvPr id="10" name="TextBox 9"/>
+          <p:cNvSpPr txBox="1"/>
+          <p:nvPr/>
+        </p:nvSpPr>
+        <p:spPr>
+          <a:xfrm>
+            <a:off x="685800" y="6419088"/>
+            <a:ext cx="7315200" cy="274320"/>
+          </a:xfrm>
+          <a:prstGeom prst="rect">
+            <a:avLst/>
+          </a:prstGeom>
+          <a:noFill/>
+        </p:spPr>
+        <p:txBody>
+          <a:bodyPr wrap="square">
+            <a:spAutoFit/>
+          </a:bodyPr>
+          <a:lstStyle/>
+          <a:p>
+            <a:r>
+              <a:rPr sz="900" b="0">
+                <a:solidFill>
+                  <a:srgbClr val="7B838F"/>
+                </a:solidFill>
+                <a:latin typeface="Calibri"/>
+              </a:rPr>
+              <a:t>NeuFlow v3  ·  progress update</a:t>
+            </a:r>
+          </a:p>
+        </p:txBody>
+      </p:sp>
+      <p:sp>
+        <p:nvSpPr>
+          <p:cNvPr id="11" name="TextBox 10"/>
+          <p:cNvSpPr txBox="1"/>
+          <p:nvPr/>
+        </p:nvSpPr>
+        <p:spPr>
+          <a:xfrm>
+            <a:off x="10607040" y="6419088"/>
+            <a:ext cx="1097280" cy="274320"/>
+          </a:xfrm>
+          <a:prstGeom prst="rect">
+            <a:avLst/>
+          </a:prstGeom>
+          <a:noFill/>
+        </p:spPr>
+        <p:txBody>
+          <a:bodyPr wrap="square">
+            <a:spAutoFit/>
+          </a:bodyPr>
+          <a:lstStyle/>
+          <a:p>
+            <a:r>
+              <a:rPr sz="900" b="0">
+                <a:solidFill>
+                  <a:srgbClr val="7B838F"/>
+                </a:solidFill>
+                <a:latin typeface="Calibri"/>
+              </a:rPr>
+              <a:t>8</a:t>
+            </a:r>
+          </a:p>
+        </p:txBody>
+      </p:sp>
+    </p:spTree>
+  </p:cSld>
+  <p:clrMapOvr>
+    <a:masterClrMapping/>
+  </p:clrMapOvr>
 </p:sld>
 </file>
 

</xml_diff>